<commit_message>
docs: finalise presentation and API documentation for submission
</commit_message>
<xml_diff>
--- a/docs/PRESENTATION.pptx
+++ b/docs/PRESENTATION.pptx
@@ -4834,7 +4834,7 @@
               </a:defRPr>
             </a:pPr>
             <a:r>
-              <a:t>[Screenshot placeholder: architecture diagram]</a:t>
+              <a:t>FastAPI → SQLAlchemy ORM → SQLite · X-API-Key middleware · /docs auto-generated · /ui/ served from /static</a:t>
             </a:r>
           </a:p>
         </p:txBody>
@@ -6252,7 +6252,7 @@
               </a:defRPr>
             </a:pPr>
             <a:r>
-              <a:t>[Screenshot placeholder: pytest -v output]</a:t>
+              <a:t>All 14 tests passing (pytest -v): 4 auth · 3 habits CRUD · 7 logs &amp; analytics — 0 failures</a:t>
             </a:r>
           </a:p>
         </p:txBody>
@@ -6557,7 +6557,7 @@
               </a:defRPr>
             </a:pPr>
             <a:r>
-              <a:t>[Screenshot placeholder: git log --oneline terminal output]</a:t>
+              <a:t>49 commits on main — conventional commit messages (feat / fix / docs / test / chore)</a:t>
             </a:r>
           </a:p>
         </p:txBody>
@@ -6972,7 +6972,7 @@
               </a:defRPr>
             </a:pPr>
             <a:r>
-              <a:t>[Screenshot placeholder: Render dashboard / /habits 200]</a:t>
+              <a:t>Live on Render — /health 200 ✓  /docs 200 ✓  /api/habits 200 ✓  /ui/ 200 ✓</a:t>
             </a:r>
           </a:p>
         </p:txBody>

</xml_diff>

<commit_message>
docs: final presentation polish — fix slide 1 layout, update deliverables slide
</commit_message>
<xml_diff>
--- a/docs/PRESENTATION.pptx
+++ b/docs/PRESENTATION.pptx
@@ -3111,8 +3111,8 @@
         </p:nvSpPr>
         <p:spPr>
           <a:xfrm>
-            <a:off x="457200" y="1828800"/>
-            <a:ext cx="8229600" cy="1371600"/>
+            <a:off x="457200" y="914400"/>
+            <a:ext cx="8229600" cy="2286000"/>
           </a:xfrm>
           <a:prstGeom prst="rect">
             <a:avLst/>
@@ -3121,23 +3121,61 @@
         </p:spPr>
         <p:txBody>
           <a:bodyPr wrap="square">
-            <a:spAutoFit/>
+            <a:noAutofit/>
           </a:bodyPr>
           <a:lstStyle/>
           <a:p>
             <a:pPr algn="ctr">
-              <a:defRPr sz="5400" b="1">
+              <a:spcBef>
+                <a:spcPts val="0"/>
+              </a:spcBef>
+              <a:spcAft>
+                <a:spcPts val="0"/>
+              </a:spcAft>
+            </a:pPr>
+            <a:r>
+              <a:rPr sz="4000" b="1">
                 <a:solidFill>
                   <a:srgbClr val="F5F5F5"/>
                 </a:solidFill>
-              </a:defRPr>
-            </a:pPr>
-            <a:r>
+              </a:rPr>
               <a:t>COMP3011:</a:t>
             </a:r>
-            <a:br/>
-            <a:r>
-              <a:t>Habit &amp; Productivity Analytics API</a:t>
+          </a:p>
+          <a:p>
+            <a:pPr algn="ctr">
+              <a:spcBef>
+                <a:spcPts val="400"/>
+              </a:spcBef>
+              <a:spcAft>
+                <a:spcPts val="0"/>
+              </a:spcAft>
+            </a:pPr>
+            <a:r>
+              <a:rPr sz="4000" b="1">
+                <a:solidFill>
+                  <a:srgbClr val="F5F5F5"/>
+                </a:solidFill>
+              </a:rPr>
+              <a:t>Habit &amp; Productivity</a:t>
+            </a:r>
+          </a:p>
+          <a:p>
+            <a:pPr algn="ctr">
+              <a:spcBef>
+                <a:spcPts val="400"/>
+              </a:spcBef>
+              <a:spcAft>
+                <a:spcPts val="0"/>
+              </a:spcAft>
+            </a:pPr>
+            <a:r>
+              <a:rPr sz="4000" b="1">
+                <a:solidFill>
+                  <a:srgbClr val="F5F5F5"/>
+                </a:solidFill>
+              </a:rPr>
+              <a:t>Analytics API</a:t>
             </a:r>
           </a:p>
         </p:txBody>
@@ -3150,8 +3188,8 @@
         </p:nvSpPr>
         <p:spPr>
           <a:xfrm>
-            <a:off x="457200" y="3474720"/>
-            <a:ext cx="8229600" cy="914400"/>
+            <a:off x="914400" y="3429000"/>
+            <a:ext cx="7315200" cy="914400"/>
           </a:xfrm>
           <a:prstGeom prst="rect">
             <a:avLst/>
@@ -3160,19 +3198,18 @@
         </p:spPr>
         <p:txBody>
           <a:bodyPr wrap="square">
-            <a:spAutoFit/>
+            <a:noAutofit/>
           </a:bodyPr>
           <a:lstStyle/>
           <a:p>
-            <a:pPr algn="ctr">
-              <a:defRPr sz="2400">
-                <a:solidFill>
-                  <a:srgbClr val="BFBFBF"/>
-                </a:solidFill>
-              </a:defRPr>
-            </a:pPr>
-            <a:r>
-              <a:t>Building a modern data-driven system for habit tracking and analytics</a:t>
+            <a:pPr algn="ctr"/>
+            <a:r>
+              <a:rPr sz="1800" b="0">
+                <a:solidFill>
+                  <a:srgbClr val="A0A0A0"/>
+                </a:solidFill>
+              </a:rPr>
+              <a:t>Building a modern data-driven system for habit tracking and productivity analytics</a:t>
             </a:r>
           </a:p>
         </p:txBody>
@@ -3185,7 +3222,7 @@
         </p:nvSpPr>
         <p:spPr>
           <a:xfrm>
-            <a:off x="2743200" y="4754880"/>
+            <a:off x="2743200" y="4663440"/>
             <a:ext cx="3657600" cy="137160"/>
           </a:xfrm>
           <a:prstGeom prst="roundRect">
@@ -5332,7 +5369,7 @@
               </a:defRPr>
             </a:pPr>
             <a:r>
-              <a:t>14</a:t>
+              <a:t>14/14 tests passing</a:t>
             </a:r>
           </a:p>
         </p:txBody>
@@ -6863,7 +6900,7 @@
               </a:defRPr>
             </a:pPr>
             <a:r>
-              <a:t>Simple API. Real Impact.</a:t>
+              <a:t>Deliverables &amp; Resources</a:t>
             </a:r>
           </a:p>
         </p:txBody>
@@ -6876,8 +6913,8 @@
         </p:nvSpPr>
         <p:spPr>
           <a:xfrm>
-            <a:off x="914400" y="2651760"/>
-            <a:ext cx="7315200" cy="1371600"/>
+            <a:off x="1371600" y="3017520"/>
+            <a:ext cx="6400800" cy="2743200"/>
           </a:xfrm>
           <a:prstGeom prst="rect">
             <a:avLst/>
@@ -6890,113 +6927,73 @@
           </a:bodyPr>
           <a:lstStyle/>
           <a:p>
-            <a:pPr algn="ctr">
-              <a:spcAft>
-                <a:spcPts val="800"/>
-              </a:spcAft>
-              <a:defRPr sz="1800">
-                <a:solidFill>
-                  <a:srgbClr val="BFBFBF"/>
-                </a:solidFill>
-              </a:defRPr>
-            </a:pPr>
-            <a:r>
-              <a:t>A complete, production-ready system for habit tracking and analytics.</a:t>
-            </a:r>
-          </a:p>
-          <a:p>
-            <a:pPr algn="ctr">
-              <a:defRPr sz="1600">
-                <a:solidFill>
-                  <a:srgbClr val="BFBFBF"/>
-                </a:solidFill>
-              </a:defRPr>
-            </a:pPr>
-            <a:r>
-              <a:t>Deployed on Render. Fully tested. Documented. Ready.</a:t>
-            </a:r>
-          </a:p>
-        </p:txBody>
-      </p:sp>
-      <p:sp>
-        <p:nvSpPr>
-          <p:cNvPr id="4" name="TextBox 3"/>
-          <p:cNvSpPr txBox="1"/>
-          <p:nvPr/>
-        </p:nvSpPr>
-        <p:spPr>
-          <a:xfrm>
-            <a:off x="914400" y="4389120"/>
-            <a:ext cx="7315200" cy="1828800"/>
-          </a:xfrm>
-          <a:prstGeom prst="rect">
-            <a:avLst/>
-          </a:prstGeom>
-          <a:noFill/>
-        </p:spPr>
-        <p:txBody>
-          <a:bodyPr wrap="square">
-            <a:spAutoFit/>
-          </a:bodyPr>
-          <a:lstStyle/>
-          <a:p>
-            <a:pPr algn="ctr">
+            <a:pPr algn="l">
+              <a:spcBef>
+                <a:spcPts val="0"/>
+              </a:spcBef>
               <a:spcAft>
                 <a:spcPts val="600"/>
               </a:spcAft>
-              <a:defRPr sz="1400" b="1">
-                <a:solidFill>
-                  <a:srgbClr val="06B6D4"/>
-                </a:solidFill>
-              </a:defRPr>
-            </a:pPr>
-            <a:r>
-              <a:t>Resources:</a:t>
-            </a:r>
-          </a:p>
-          <a:p>
-            <a:pPr algn="ctr">
+              <a:defRPr sz="1800">
+                <a:solidFill>
+                  <a:srgbClr val="BFBFBF"/>
+                </a:solidFill>
+              </a:defRPr>
+            </a:pPr>
+            <a:r>
+              <a:t>•  Technical Report (PDF)</a:t>
+            </a:r>
+          </a:p>
+          <a:p>
+            <a:pPr algn="l">
               <a:spcBef>
-                <a:spcPts val="300"/>
+                <a:spcPts val="600"/>
               </a:spcBef>
-              <a:defRPr sz="1100">
-                <a:solidFill>
-                  <a:srgbClr val="F5F5F5"/>
-                </a:solidFill>
-              </a:defRPr>
-            </a:pPr>
-            <a:r>
-              <a:t>📖 Technical Report (5 pages detailed)</a:t>
-            </a:r>
-          </a:p>
-          <a:p>
-            <a:pPr algn="ctr">
+              <a:spcAft>
+                <a:spcPts val="600"/>
+              </a:spcAft>
+            </a:pPr>
+            <a:r>
+              <a:t>•  API Documentation (PDF)</a:t>
+            </a:r>
+          </a:p>
+          <a:p>
+            <a:pPr algn="l">
               <a:spcBef>
-                <a:spcPts val="300"/>
+                <a:spcPts val="600"/>
               </a:spcBef>
-              <a:defRPr sz="1100">
-                <a:solidFill>
-                  <a:srgbClr val="F5F5F5"/>
-                </a:solidFill>
-              </a:defRPr>
-            </a:pPr>
-            <a:r>
-              <a:t>📝 API Documentation (Swagger)</a:t>
-            </a:r>
-          </a:p>
-          <a:p>
-            <a:pPr algn="ctr">
+              <a:spcAft>
+                <a:spcPts val="600"/>
+              </a:spcAft>
+            </a:pPr>
+            <a:r>
+              <a:t>•  Presentation Slides (PPTX)</a:t>
+            </a:r>
+          </a:p>
+          <a:p>
+            <a:pPr algn="l">
               <a:spcBef>
-                <a:spcPts val="300"/>
+                <a:spcPts val="600"/>
               </a:spcBef>
-              <a:defRPr sz="1100">
-                <a:solidFill>
-                  <a:srgbClr val="F5F5F5"/>
-                </a:solidFill>
-              </a:defRPr>
-            </a:pPr>
-            <a:r>
-              <a:t>💾 Source: github.com/NicolasIssa1/COMP3011-CW1-HABIT-API</a:t>
+              <a:spcAft>
+                <a:spcPts val="600"/>
+              </a:spcAft>
+            </a:pPr>
+            <a:r>
+              <a:t>•  Public GitHub Repository</a:t>
+            </a:r>
+          </a:p>
+          <a:p>
+            <a:pPr algn="l">
+              <a:spcBef>
+                <a:spcPts val="600"/>
+              </a:spcBef>
+              <a:spcAft>
+                <a:spcPts val="0"/>
+              </a:spcAft>
+            </a:pPr>
+            <a:r>
+              <a:t>•  Live Render Deployment</a:t>
             </a:r>
           </a:p>
         </p:txBody>

</xml_diff>